<commit_message>
Restructure contest docs into five sections and keep only MetaLab photos.
Co-authored-by: Cursor <cursoragent@cursor.com>
</commit_message>
<xml_diff>
--- a/presentation-materials/CodeSensei-NEXT-presentation.pptx
+++ b/presentation-materials/CodeSensei-NEXT-presentation.pptx
@@ -8230,7 +8230,7 @@
             </a:pPr>
             <a:r>
               <a:rPr lang="en-GB" sz="2300"/>
-              <a:t>MetaLab is the university multimedia space established under Erasmus+ NEXT. It is the physical counterpart of the virtual classroom where students practise digital and programming skills.</a:t>
+              <a:t>Built in VRChat (SDK3, UdonSharp) inside our MetaLab hall — the digital twin of KPI MacPaw AI Lab — using .NET 10, Render and Google Gemini.</a:t>
             </a:r>
             <a:endParaRPr sz="2300"/>
           </a:p>
@@ -8268,7 +8268,7 @@
             </a:pPr>
             <a:r>
               <a:rPr lang="en-GB" sz="2300"/>
-              <a:t>Student workstation with the CodeSensei terminal; 24 OOP preset buttons; code-review station (5-character ticket + /paste); shared display for collaborative learning.</a:t>
+              <a:t>Practical parts: 24 OOP preset buttons; code-review ticket + /paste; shared terminal display in our MetaLab hall.</a:t>
             </a:r>
             <a:endParaRPr sz="2000"/>
           </a:p>
@@ -8469,7 +8469,7 @@
                   <a:schemeClr val="dk1"/>
                 </a:solidFill>
               </a:rPr>
-              <a:t>MetaLab workstation — reference interior</a:t>
+              <a:t>MetaLab overview — our laboratory</a:t>
             </a:r>
             <a:endParaRPr sz="3000">
               <a:solidFill>
@@ -8512,7 +8512,7 @@
                   <a:schemeClr val="dk1"/>
                 </a:solidFill>
               </a:rPr>
-              <a:t>Campus context, Igor Sikorsky KPI</a:t>
+              <a:t>MetaLab lounge — virtual classroom</a:t>
             </a:r>
             <a:endParaRPr sz="2500">
               <a:solidFill>
@@ -8743,7 +8743,7 @@
                   <a:schemeClr val="dk1"/>
                 </a:solidFill>
               </a:rPr>
-              <a:t>CodeSensei terminal in the virtual laboratory</a:t>
+              <a:t>MetaLab virtual laboratory</a:t>
             </a:r>
             <a:endParaRPr sz="3000">
               <a:solidFill>
@@ -8786,7 +8786,7 @@
                   <a:schemeClr val="dk1"/>
                 </a:solidFill>
               </a:rPr>
-              <a:t>UdonSharp terminal with 55-character lines</a:t>
+              <a:t>Workstations in the MetaLab world</a:t>
             </a:r>
             <a:endParaRPr sz="2500">
               <a:solidFill>
@@ -9682,7 +9682,7 @@
             </a:pPr>
             <a:r>
               <a:rPr lang="en-GB" sz="2300"/>
-              <a:t>Udon cannot POST, so review is ticket + /paste + inbox. Render Free sleeps — /health wakes the instance. Pending tickets are hidden so the client does not stop polling early.</a:t>
+              <a:t>Limits: Udon cannot POST; Untrusted URLs required; Render Free sleeps; tickets live in memory; VR lines max 55 characters.</a:t>
             </a:r>
             <a:endParaRPr sz="2300"/>
           </a:p>
@@ -9946,7 +9946,7 @@
             </a:pPr>
             <a:r>
               <a:rPr lang="en-GB" sz="2300"/>
-              <a:t>Persistent ticket store, more languages, keep-alive Action, additional lab furniture, and a public VRChat world listing after MetaLab import.</a:t>
+              <a:t>Persistent ticket store, more languages, keep-alive hosting, extra OOP topics, public world listing after MetaLab import.</a:t>
             </a:r>
             <a:endParaRPr sz="2300"/>
           </a:p>
@@ -10135,7 +10135,7 @@
             </a:pPr>
             <a:r>
               <a:rPr lang="en-GB" sz="2300"/>
-              <a:t>VRChat: https://hello.vrchat.com/   NEXT: https://nextstudy.eu/   Integration notes: docs/NEXT-INTEGRATION.md</a:t>
+              <a:t>VRChat: https://hello.vrchat.com/   NEXT: https://nextstudy.eu/   Docs: presentation-materials/documentation/DOCUMENTATION.md</a:t>
             </a:r>
             <a:endParaRPr sz="2300"/>
           </a:p>

</xml_diff>

<commit_message>
Expand the contest write-up and align the slides with it.
Co-authored-by: Cursor <cursoragent@cursor.com>
</commit_message>
<xml_diff>
--- a/presentation-materials/CodeSensei-NEXT-presentation.pptx
+++ b/presentation-materials/CodeSensei-NEXT-presentation.pptx
@@ -7316,7 +7316,7 @@
                   <a:schemeClr val="dk1"/>
                 </a:solidFill>
               </a:rPr>
-              <a:t>CodeSensei authors</a:t>
+              <a:t>Five authors</a:t>
             </a:r>
             <a:endParaRPr b="1" sz="2200">
               <a:solidFill>
@@ -7407,7 +7407,7 @@
                   <a:schemeClr val="dk1"/>
                 </a:solidFill>
               </a:rPr>
-              <a:t>Authorship of created artefacts remains with the team.</a:t>
+              <a:t>Artefacts stay with the five authors. NEXT may use them for teaching.</a:t>
             </a:r>
             <a:endParaRPr sz="2000">
               <a:solidFill>
@@ -7457,7 +7457,7 @@
             </a:r>
             <a:r>
               <a:rPr i="1" lang="en-GB" sz="2000"/>
-              <a:t> Five authors; artefacts remain the team’s IP.</a:t>
+              <a:t> Five people. Artefacts stay with the team.</a:t>
             </a:r>
             <a:endParaRPr i="1" sz="2000"/>
           </a:p>
@@ -8230,7 +8230,7 @@
             </a:pPr>
             <a:r>
               <a:rPr lang="en-GB" sz="2300"/>
-              <a:t>Built in VRChat (SDK3, UdonSharp) inside our MetaLab hall — the digital twin of KPI MacPaw AI Lab — using .NET 10, Render and Google Gemini.</a:t>
+              <a:t>Our MetaLab hall at Igor Sikorsky KPI, a VRChat twin of MacPaw AI Lab. CodeSensei is the mentor in this room: UdonSharp on the client, a .NET 10 proxy on Render, Google Gemini behind it.</a:t>
             </a:r>
             <a:endParaRPr sz="2300"/>
           </a:p>
@@ -8268,7 +8268,7 @@
             </a:pPr>
             <a:r>
               <a:rPr lang="en-GB" sz="2300"/>
-              <a:t>Practical parts: 24 OOP preset buttons; code-review ticket + /paste; shared terminal display in our MetaLab hall.</a:t>
+              <a:t>In this hall: 24 OOP topics, a five-character review ticket, the /paste page, and one shared screen for the group.</a:t>
             </a:r>
             <a:endParaRPr sz="2000"/>
           </a:p>
@@ -9077,7 +9077,7 @@
             </a:pPr>
             <a:r>
               <a:rPr lang="en-GB" sz="2000"/>
-              <a:t>VRChat prefab: UdonSharp terminal, 5.5 s GET queue, synced answers.</a:t>
+              <a:t>UdonSharp prefab in MetaLab. The answer syncs, so the group reads the same lines.</a:t>
             </a:r>
             <a:endParaRPr sz="2000"/>
           </a:p>
@@ -9213,7 +9213,7 @@
             </a:pPr>
             <a:r>
               <a:rPr lang="en-GB" sz="2000"/>
-              <a:t>24 OOP topics (encapsulation to OOP vs procedural) on preset buttons.</a:t>
+              <a:t>Twenty-four short OOP explanations, from encapsulation to class versus object.</a:t>
             </a:r>
             <a:endParaRPr sz="2000"/>
           </a:p>
@@ -9349,7 +9349,7 @@
             </a:pPr>
             <a:r>
               <a:rPr lang="en-GB" sz="2000"/>
-              <a:t>Student gets a 5-character code, pastes a snippet, Gemini replies on the VR screen.</a:t>
+              <a:t>A five-character code, a C# snippet on /paste, then the Gemini review on the VR screen.</a:t>
             </a:r>
             <a:endParaRPr sz="2000"/>
           </a:p>
@@ -9682,7 +9682,7 @@
             </a:pPr>
             <a:r>
               <a:rPr lang="en-GB" sz="2300"/>
-              <a:t>Limits: Udon cannot POST; Untrusted URLs required; Render Free sleeps; tickets live in memory; VR lines max 55 characters.</a:t>
+              <a:t>Udon cannot POST, so review is a ticket plus /paste. VRChat blocks our host until Allow Untrusted URLs is on. Render Free sleeps. Tickets stay in memory. Lines wrap at 55 characters.</a:t>
             </a:r>
             <a:endParaRPr sz="2300"/>
           </a:p>
@@ -9882,7 +9882,7 @@
             </a:pPr>
             <a:r>
               <a:rPr lang="en-GB" sz="2300"/>
-              <a:t>In the NEXT-Study Metaverse lab a student presses an OOP preset or starts a live code review. A teacher sees the same synced answer on the shared terminal.</a:t>
+              <a:t>In the MetaLab hall a student opens an OOP preset or starts a review. The teacher and the group see the same synced text.</a:t>
             </a:r>
             <a:endParaRPr sz="2300"/>
           </a:p>
@@ -9914,7 +9914,7 @@
             </a:pPr>
             <a:r>
               <a:rPr lang="en-GB" sz="2300"/>
-              <a:t>Explore 24 OOP explanations, generate a review ticket, paste a snippet on the web form, and read a mentor reply formatted for the VR screen (max 55 characters per line).</a:t>
+              <a:t>Visitors read 24 short explanations, take a review ticket, paste a snippet, and read a mentor reply fitted to the VR screen.</a:t>
             </a:r>
             <a:endParaRPr sz="2300"/>
           </a:p>
@@ -9946,7 +9946,7 @@
             </a:pPr>
             <a:r>
               <a:rPr lang="en-GB" sz="2300"/>
-              <a:t>Persistent ticket store, more languages, keep-alive hosting, extra OOP topics, public world listing after MetaLab import.</a:t>
+              <a:t>Next: a ticket store that survives restarts, more languages, a host that stays awake, extra topics, and a public listing once the prefab stays in MetaLab.</a:t>
             </a:r>
             <a:endParaRPr sz="2300"/>
           </a:p>

</xml_diff>